<commit_message>
Docs: THOR-first framing, new viewer screenshots
THOR is the detector and the CA-CFAR the baseline throughout: README, the
viewer's About dialog, CLAUDE.md (project description, status, Milestone 7
plan for the code changes), and the presentations (Project Brief v2 deck and
one-pager rebuilt around THOR; CA-CFAR vs THOR brief refreshed).

The headline is the matched-count comparison (THOR 0.84 vs CFAR 0.74 on four
held-out passes). validation-findings.md notes why the earlier CFAR 78% isn't
comparable. New screenshots show THOR rings and a per-pass recall chart.

Co-Authored-By: Claude Opus 5.5 <noreply@anthropic.com>
</commit_message>
<xml_diff>
--- a/docs/presentation/CA-CFAR vs THOR — Brief.pptx
+++ b/docs/presentation/CA-CFAR vs THOR — Brief.pptx
@@ -1883,14 +1883,13 @@
           <p:nvPr/>
         </p:nvPicPr>
         <p:blipFill>
-          <a:blip r:embed="rId1"/>
-          <a:srcRect l="26042" r="26042" t="0" b="0"/>
+          <a:blip r:embed="rId4"/>
           <a:stretch/>
         </p:blipFill>
         <p:spPr>
           <a:xfrm>
             <a:off x="6350000" y="0"/>
-            <a:ext cx="5842000" cy="6858000"/>
+            <a:ext cx="5836920" cy="6858000"/>
           </a:xfrm>
           <a:prstGeom prst="rect">
             <a:avLst/>

</xml_diff>